<commit_message>
fix(copilot): complete financial accuracy repair, eliminate overhead double-counting, update repo name to Finova-Finpilot
</commit_message>
<xml_diff>
--- a/submission/presentation.pptx
+++ b/submission/presentation.pptx
@@ -4170,7 +4170,7 @@
               </a:defRPr>
             </a:pPr>
             <a:r>
-              <a:t>•   Root Cause Analysis: Detects that 73.8% of spending is concentrated in fixed overheads (Rent 41.8%, Salary 32.0%).</a:t>
+              <a:t>•   Root Cause Analysis: Audits categories on 100% denominator, detects $2.95M in facility costs &amp; 82 duplicate entries ($603k).</a:t>
             </a:r>
           </a:p>
           <a:p>
@@ -4186,7 +4186,7 @@
               </a:defRPr>
             </a:pPr>
             <a:r>
-              <a:t>•   Prioritized 3-Phase Plan: 15-day liquidity defense ($89.3k receivables dunning), 45-day overhead cut, 90-day margin acceleration.</a:t>
+              <a:t>•   Working Capital Distinction: Distinguishes uncollected receivables ($89.3k) and inventory at cost ($2.45M) from immediate cash.</a:t>
             </a:r>
           </a:p>
           <a:p>
@@ -4202,7 +4202,7 @@
               </a:defRPr>
             </a:pPr>
             <a:r>
-              <a:t>•   Quantified Turnaround Scenarios: 5% expense cut = +$243,408; 10% sales lift = +$152,540; combined = +$639,357.</a:t>
+              <a:t>•   Quantified Scenarios: 5% expense cut = +$243,408; 10% sales lift = +$152,540 top-line revenue; combined gross relief = +$395,949.</a:t>
             </a:r>
           </a:p>
         </p:txBody>

</xml_diff>